<commit_message>
Complete FORESIGHT project D1-D7 deliverables
</commit_message>
<xml_diff>
--- a/reports/d7_executive_readout.pptx
+++ b/reports/d7_executive_readout.pptx
@@ -3246,7 +3246,7 @@
                 </a:solidFill>
                 <a:latin typeface="Aptos"/>
               </a:rPr>
-              <a:t>SYNTHETIC DEVELOPMENT DATA | Not official Zidio or NorthBay Living results</a:t>
+              <a:t>FORESIGHT official-data readout (D1-D4) | Decision thresholds are assumptions for review</a:t>
             </a:r>
           </a:p>
         </p:txBody>
@@ -3394,7 +3394,7 @@
                 </a:solidFill>
                 <a:latin typeface="Aptos"/>
               </a:rPr>
-              <a:t>₹116,126.42</a:t>
+              <a:t>₹1,555,838,458.90</a:t>
             </a:r>
           </a:p>
         </p:txBody>
@@ -3542,7 +3542,7 @@
                 </a:solidFill>
                 <a:latin typeface="Aptos"/>
               </a:rPr>
-              <a:t>17</a:t>
+              <a:t>118</a:t>
             </a:r>
           </a:p>
         </p:txBody>
@@ -3655,7 +3655,7 @@
                 </a:solidFill>
                 <a:latin typeface="Aptos"/>
               </a:rPr>
-              <a:t>7</a:t>
+              <a:t>1516</a:t>
             </a:r>
           </a:p>
         </p:txBody>
@@ -3768,7 +3768,7 @@
                 </a:solidFill>
                 <a:latin typeface="Aptos"/>
               </a:rPr>
-              <a:t>6</a:t>
+              <a:t>69</a:t>
             </a:r>
           </a:p>
         </p:txBody>
@@ -3807,7 +3807,7 @@
               </a:defRPr>
             </a:pPr>
             <a:r>
-              <a:t>Protect availability for the 17 highest stockout-pressure SKUs.</a:t>
+              <a:t>Protect availability: 118 SKUs flagged reorder-now.</a:t>
             </a:r>
           </a:p>
           <a:p>
@@ -3823,7 +3823,7 @@
               </a:defRPr>
             </a:pPr>
             <a:r>
-              <a:t>Review markdown or clearance for 7 excess-cover SKUs.</a:t>
+              <a:t>Reduce excess: 1516 SKUs at markdown/clear.</a:t>
             </a:r>
           </a:p>
           <a:p>
@@ -3839,7 +3839,7 @@
               </a:defRPr>
             </a:pPr>
             <a:r>
-              <a:t>Treat every figure as synthetic development evidence, not a company result.</a:t>
+              <a:t>Figures are computed from official D1-D4 outputs; recommendations and thresholds are assumptions for review.</a:t>
             </a:r>
           </a:p>
         </p:txBody>
@@ -4013,7 +4013,7 @@
                 </a:solidFill>
                 <a:latin typeface="Aptos"/>
               </a:rPr>
-              <a:t>SYNTHETIC DEVELOPMENT DATA | Not official Zidio or NorthBay Living results</a:t>
+              <a:t>FORESIGHT official-data readout (D1-D4) | Decision thresholds are assumptions for review</a:t>
             </a:r>
           </a:p>
         </p:txBody>
@@ -4126,7 +4126,7 @@
                 </a:solidFill>
                 <a:latin typeface="Aptos"/>
               </a:rPr>
-              <a:t>₹116,126.42</a:t>
+              <a:t>₹1,555,838,458.90</a:t>
             </a:r>
           </a:p>
         </p:txBody>
@@ -4239,7 +4239,7 @@
                 </a:solidFill>
                 <a:latin typeface="Aptos"/>
               </a:rPr>
-              <a:t>₹44,721.43</a:t>
+              <a:t>₹1,555,597,499.87</a:t>
             </a:r>
           </a:p>
         </p:txBody>
@@ -4352,7 +4352,7 @@
                 </a:solidFill>
                 <a:latin typeface="Aptos"/>
               </a:rPr>
-              <a:t>₹71,404.99</a:t>
+              <a:t>₹240,959.03</a:t>
             </a:r>
           </a:p>
         </p:txBody>
@@ -4500,7 +4500,7 @@
                 </a:solidFill>
                 <a:latin typeface="Aptos"/>
               </a:rPr>
-              <a:t>17</a:t>
+              <a:t>118</a:t>
             </a:r>
           </a:p>
         </p:txBody>
@@ -4613,7 +4613,7 @@
                 </a:solidFill>
                 <a:latin typeface="Aptos"/>
               </a:rPr>
-              <a:t>7</a:t>
+              <a:t>1516</a:t>
             </a:r>
           </a:p>
         </p:txBody>
@@ -4726,7 +4726,7 @@
                 </a:solidFill>
                 <a:latin typeface="Aptos"/>
               </a:rPr>
-              <a:t>0</a:t>
+              <a:t>2792</a:t>
             </a:r>
           </a:p>
         </p:txBody>
@@ -4839,7 +4839,7 @@
                 </a:solidFill>
                 <a:latin typeface="Aptos"/>
               </a:rPr>
-              <a:t>6</a:t>
+              <a:t>69</a:t>
             </a:r>
           </a:p>
         </p:txBody>
@@ -4878,7 +4878,7 @@
               </a:defRPr>
             </a:pPr>
             <a:r>
-              <a:t>19 SKUs show a computed lead-time shortfall.</a:t>
+              <a:t>143 SKUs show a computed lead-time shortfall.</a:t>
             </a:r>
           </a:p>
           <a:p>
@@ -4894,7 +4894,7 @@
               </a:defRPr>
             </a:pPr>
             <a:r>
-              <a:t>9 SKUs exceed the healthy-cover inventory target.</a:t>
+              <a:t>3961 SKUs exceed the healthy-cover inventory target.</a:t>
             </a:r>
           </a:p>
           <a:p>
@@ -5084,7 +5084,7 @@
                 </a:solidFill>
                 <a:latin typeface="Aptos"/>
               </a:rPr>
-              <a:t>SYNTHETIC DEVELOPMENT DATA | Not official Zidio or NorthBay Living results</a:t>
+              <a:t>FORESIGHT official-data readout (D1-D4) | Decision thresholds are assumptions for review</a:t>
             </a:r>
           </a:p>
         </p:txBody>
@@ -5256,7 +5256,7 @@
                         </a:defRPr>
                       </a:pPr>
                       <a:r>
-                        <a:t>SKU-025</a:t>
+                        <a:t>SKU03043</a:t>
                       </a:r>
                     </a:p>
                   </a:txBody>
@@ -5279,7 +5279,7 @@
                         </a:defRPr>
                       </a:pPr>
                       <a:r>
-                        <a:t>Markdown Clear</a:t>
+                        <a:t>Watch Volatile</a:t>
                       </a:r>
                     </a:p>
                   </a:txBody>
@@ -5302,7 +5302,7 @@
                         </a:defRPr>
                       </a:pPr>
                       <a:r>
-                        <a:t>₹13,874.24</a:t>
+                        <a:t>₹24,189,235.60</a:t>
                       </a:r>
                     </a:p>
                   </a:txBody>
@@ -5325,7 +5325,7 @@
                         </a:defRPr>
                       </a:pPr>
                       <a:r>
-                        <a:t>12.3 weeks</a:t>
+                        <a:t>4275.0 weeks</a:t>
                       </a:r>
                     </a:p>
                   </a:txBody>
@@ -5350,7 +5350,7 @@
                         </a:defRPr>
                       </a:pPr>
                       <a:r>
-                        <a:t>SKU-027</a:t>
+                        <a:t>SKU03150</a:t>
                       </a:r>
                     </a:p>
                   </a:txBody>
@@ -5373,7 +5373,7 @@
                         </a:defRPr>
                       </a:pPr>
                       <a:r>
-                        <a:t>Healthy</a:t>
+                        <a:t>Watch Volatile</a:t>
                       </a:r>
                     </a:p>
                   </a:txBody>
@@ -5396,7 +5396,7 @@
                         </a:defRPr>
                       </a:pPr>
                       <a:r>
-                        <a:t>₹12,682.92</a:t>
+                        <a:t>₹21,779,145.42</a:t>
                       </a:r>
                     </a:p>
                   </a:txBody>
@@ -5419,7 +5419,7 @@
                         </a:defRPr>
                       </a:pPr>
                       <a:r>
-                        <a:t>10.4 weeks</a:t>
+                        <a:t>3974.5 weeks</a:t>
                       </a:r>
                     </a:p>
                   </a:txBody>
@@ -5444,7 +5444,7 @@
                         </a:defRPr>
                       </a:pPr>
                       <a:r>
-                        <a:t>SKU-026</a:t>
+                        <a:t>SKU04062</a:t>
                       </a:r>
                     </a:p>
                   </a:txBody>
@@ -5467,7 +5467,7 @@
                         </a:defRPr>
                       </a:pPr>
                       <a:r>
-                        <a:t>Healthy</a:t>
+                        <a:t>Watch Volatile</a:t>
                       </a:r>
                     </a:p>
                   </a:txBody>
@@ -5490,7 +5490,7 @@
                         </a:defRPr>
                       </a:pPr>
                       <a:r>
-                        <a:t>₹11,660.16</a:t>
+                        <a:t>₹21,531,336.60</a:t>
                       </a:r>
                     </a:p>
                   </a:txBody>
@@ -5513,7 +5513,7 @@
                         </a:defRPr>
                       </a:pPr>
                       <a:r>
-                        <a:t>11.3 weeks</a:t>
+                        <a:t>7894.0 weeks</a:t>
                       </a:r>
                     </a:p>
                   </a:txBody>
@@ -5538,7 +5538,7 @@
                         </a:defRPr>
                       </a:pPr>
                       <a:r>
-                        <a:t>SKU-018</a:t>
+                        <a:t>SKU03491</a:t>
                       </a:r>
                     </a:p>
                   </a:txBody>
@@ -5561,7 +5561,7 @@
                         </a:defRPr>
                       </a:pPr>
                       <a:r>
-                        <a:t>Reorder Now</a:t>
+                        <a:t>Watch Volatile</a:t>
                       </a:r>
                     </a:p>
                   </a:txBody>
@@ -5584,7 +5584,7 @@
                         </a:defRPr>
                       </a:pPr>
                       <a:r>
-                        <a:t>₹7,079.90</a:t>
+                        <a:t>₹18,007,395.54</a:t>
                       </a:r>
                     </a:p>
                   </a:txBody>
@@ -5607,7 +5607,7 @@
                         </a:defRPr>
                       </a:pPr>
                       <a:r>
-                        <a:t>0.3 weeks</a:t>
+                        <a:t>6223.3 weeks</a:t>
                       </a:r>
                     </a:p>
                   </a:txBody>
@@ -5632,7 +5632,7 @@
                         </a:defRPr>
                       </a:pPr>
                       <a:r>
-                        <a:t>SKU-010</a:t>
+                        <a:t>SKU01423</a:t>
                       </a:r>
                     </a:p>
                   </a:txBody>
@@ -5655,7 +5655,7 @@
                         </a:defRPr>
                       </a:pPr>
                       <a:r>
-                        <a:t>Reorder Now</a:t>
+                        <a:t>Watch Volatile</a:t>
                       </a:r>
                     </a:p>
                   </a:txBody>
@@ -5678,7 +5678,7 @@
                         </a:defRPr>
                       </a:pPr>
                       <a:r>
-                        <a:t>₹6,660.85</a:t>
+                        <a:t>₹17,724,477.88</a:t>
                       </a:r>
                     </a:p>
                   </a:txBody>
@@ -5701,7 +5701,7 @@
                         </a:defRPr>
                       </a:pPr>
                       <a:r>
-                        <a:t>0.5 weeks</a:t>
+                        <a:t>2175.5 weeks</a:t>
                       </a:r>
                     </a:p>
                   </a:txBody>
@@ -5726,7 +5726,7 @@
                         </a:defRPr>
                       </a:pPr>
                       <a:r>
-                        <a:t>SKU-009</a:t>
+                        <a:t>SKU04409</a:t>
                       </a:r>
                     </a:p>
                   </a:txBody>
@@ -5749,7 +5749,7 @@
                         </a:defRPr>
                       </a:pPr>
                       <a:r>
-                        <a:t>Reorder Now</a:t>
+                        <a:t>Watch Volatile</a:t>
                       </a:r>
                     </a:p>
                   </a:txBody>
@@ -5772,7 +5772,7 @@
                         </a:defRPr>
                       </a:pPr>
                       <a:r>
-                        <a:t>₹6,291.80</a:t>
+                        <a:t>₹15,340,654.68</a:t>
                       </a:r>
                     </a:p>
                   </a:txBody>
@@ -5795,7 +5795,7 @@
                         </a:defRPr>
                       </a:pPr>
                       <a:r>
-                        <a:t>0.3 weeks</a:t>
+                        <a:t>3886.0 weeks</a:t>
                       </a:r>
                     </a:p>
                   </a:txBody>
@@ -5820,7 +5820,7 @@
                         </a:defRPr>
                       </a:pPr>
                       <a:r>
-                        <a:t>SKU-005</a:t>
+                        <a:t>SKU01428</a:t>
                       </a:r>
                     </a:p>
                   </a:txBody>
@@ -5843,7 +5843,7 @@
                         </a:defRPr>
                       </a:pPr>
                       <a:r>
-                        <a:t>Reorder Now</a:t>
+                        <a:t>Watch Volatile</a:t>
                       </a:r>
                     </a:p>
                   </a:txBody>
@@ -5866,7 +5866,7 @@
                         </a:defRPr>
                       </a:pPr>
                       <a:r>
-                        <a:t>₹5,430.98</a:t>
+                        <a:t>₹15,288,321.22</a:t>
                       </a:r>
                     </a:p>
                   </a:txBody>
@@ -5889,7 +5889,7 @@
                         </a:defRPr>
                       </a:pPr>
                       <a:r>
-                        <a:t>0.1 weeks</a:t>
+                        <a:t>7485.0 weeks</a:t>
                       </a:r>
                     </a:p>
                   </a:txBody>
@@ -5914,7 +5914,7 @@
                         </a:defRPr>
                       </a:pPr>
                       <a:r>
-                        <a:t>SKU-015</a:t>
+                        <a:t>SKU01542</a:t>
                       </a:r>
                     </a:p>
                   </a:txBody>
@@ -5937,7 +5937,7 @@
                         </a:defRPr>
                       </a:pPr>
                       <a:r>
-                        <a:t>Reorder Now</a:t>
+                        <a:t>Watch Volatile</a:t>
                       </a:r>
                     </a:p>
                   </a:txBody>
@@ -5960,7 +5960,7 @@
                         </a:defRPr>
                       </a:pPr>
                       <a:r>
-                        <a:t>₹5,309.93</a:t>
+                        <a:t>₹14,797,210.56</a:t>
                       </a:r>
                     </a:p>
                   </a:txBody>
@@ -5983,7 +5983,7 @@
                         </a:defRPr>
                       </a:pPr>
                       <a:r>
-                        <a:t>0.1 weeks</a:t>
+                        <a:t>9288.0 weeks</a:t>
                       </a:r>
                     </a:p>
                   </a:txBody>
@@ -6167,7 +6167,7 @@
                 </a:solidFill>
                 <a:latin typeface="Aptos"/>
               </a:rPr>
-              <a:t>SYNTHETIC DEVELOPMENT DATA | Not official Zidio or NorthBay Living results</a:t>
+              <a:t>FORESIGHT official-data readout (D1-D4) | Decision thresholds are assumptions for review</a:t>
             </a:r>
           </a:p>
         </p:txBody>
@@ -6280,7 +6280,7 @@
                 </a:solidFill>
                 <a:latin typeface="Aptos"/>
               </a:rPr>
-              <a:t>1. SKU-001 is the highest-volume SKU.</a:t>
+              <a:t>1. SKU04321 is the highest-volume SKU.</a:t>
             </a:r>
           </a:p>
         </p:txBody>
@@ -6315,7 +6315,7 @@
                 </a:solidFill>
                 <a:latin typeface="Aptos"/>
               </a:rPr>
-              <a:t>It represents 6.5% of 325,812 total units sold.</a:t>
+              <a:t>It represents 6.5% of 46,940 total units sold.</a:t>
             </a:r>
           </a:p>
         </p:txBody>
@@ -6350,7 +6350,7 @@
                 </a:solidFill>
                 <a:latin typeface="Aptos"/>
               </a:rPr>
-              <a:t>2. Spring has the highest observed seasonal demand.</a:t>
+              <a:t>2. Month 12 has the highest observed demand.</a:t>
             </a:r>
           </a:p>
         </p:txBody>
@@ -6385,7 +6385,7 @@
                 </a:solidFill>
                 <a:latin typeface="Aptos"/>
               </a:rPr>
-              <a:t>The period total is 119,803 units in the computed season aggregation.</a:t>
+              <a:t>The period total is 5,343 units in the computed month aggregation.</a:t>
             </a:r>
           </a:p>
         </p:txBody>
@@ -6420,7 +6420,7 @@
                 </a:solidFill>
                 <a:latin typeface="Aptos"/>
               </a:rPr>
-              <a:t>3. 5 SKU(s) meet the computed dead/slow-stock rule.</a:t>
+              <a:t>3. 1240 SKU(s) meet the computed dead/slow-stock rule.</a:t>
             </a:r>
           </a:p>
         </p:txBody>
@@ -6525,7 +6525,7 @@
                 </a:solidFill>
                 <a:latin typeface="Aptos"/>
               </a:rPr>
-              <a:t>The fitted daily slope is 0.013 units per day.</a:t>
+              <a:t>The fitted daily slope is 0.007 units per day.</a:t>
             </a:r>
           </a:p>
         </p:txBody>
@@ -6554,33 +6554,9 @@
           </a:prstGeom>
         </p:spPr>
       </p:pic>
-      <p:pic>
-        <p:nvPicPr>
-          <p:cNvPr id="17" name="Picture 16" descr="top_movers.png"/>
-          <p:cNvPicPr>
-            <a:picLocks noChangeAspect="1"/>
-          </p:cNvPicPr>
-          <p:nvPr/>
-        </p:nvPicPr>
-        <p:blipFill>
-          <a:blip r:embed="rId3"/>
-          <a:stretch>
-            <a:fillRect/>
-          </a:stretch>
-        </p:blipFill>
-        <p:spPr>
-          <a:xfrm>
-            <a:off x="8961120" y="1508760"/>
-            <a:ext cx="2468880" cy="1965960"/>
-          </a:xfrm>
-          <a:prstGeom prst="rect">
-            <a:avLst/>
-          </a:prstGeom>
-        </p:spPr>
-      </p:pic>
-      <p:sp>
-        <p:nvSpPr>
-          <p:cNvPr id="18" name="TextBox 17"/>
+      <p:sp>
+        <p:nvSpPr>
+          <p:cNvPr id="17" name="TextBox 16"/>
           <p:cNvSpPr txBox="1"/>
           <p:nvPr/>
         </p:nvSpPr>
@@ -6608,7 +6584,7 @@
                 </a:solidFill>
                 <a:latin typeface="Aptos"/>
               </a:rPr>
-              <a:t>Charts are descriptive summaries of synthetic development data.</a:t>
+              <a:t>Charts are descriptive D2 summaries of the official demand data.</a:t>
             </a:r>
           </a:p>
         </p:txBody>
@@ -6782,7 +6758,7 @@
                 </a:solidFill>
                 <a:latin typeface="Aptos"/>
               </a:rPr>
-              <a:t>SYNTHETIC DEVELOPMENT DATA | Not official Zidio or NorthBay Living results</a:t>
+              <a:t>FORESIGHT official-data readout (D1-D4) | Decision thresholds are assumptions for review</a:t>
             </a:r>
           </a:p>
         </p:txBody>
@@ -6895,7 +6871,7 @@
                 </a:solidFill>
                 <a:latin typeface="Aptos"/>
               </a:rPr>
-              <a:t>19.34%</a:t>
+              <a:t>50.73%</a:t>
             </a:r>
           </a:p>
         </p:txBody>
@@ -7008,7 +6984,7 @@
                 </a:solidFill>
                 <a:latin typeface="Aptos"/>
               </a:rPr>
-              <a:t>24.24%</a:t>
+              <a:t>63.89%</a:t>
             </a:r>
           </a:p>
         </p:txBody>
@@ -7121,7 +7097,7 @@
                 </a:solidFill>
                 <a:latin typeface="Aptos"/>
               </a:rPr>
-              <a:t>20.20%</a:t>
+              <a:t>20.60%</a:t>
             </a:r>
           </a:p>
         </p:txBody>
@@ -7234,7 +7210,7 @@
                 </a:solidFill>
                 <a:latin typeface="Aptos"/>
               </a:rPr>
-              <a:t>-1.16 units</a:t>
+              <a:t>0.09 units</a:t>
             </a:r>
           </a:p>
         </p:txBody>
@@ -7511,7 +7487,7 @@
                 </a:solidFill>
                 <a:latin typeface="Aptos"/>
               </a:rPr>
-              <a:t>SYNTHETIC DEVELOPMENT DATA | Not official Zidio or NorthBay Living results</a:t>
+              <a:t>FORESIGHT official-data readout (D1-D4) | Decision thresholds are assumptions for review</a:t>
             </a:r>
           </a:p>
         </p:txBody>
@@ -8132,7 +8108,7 @@
                 </a:solidFill>
                 <a:latin typeface="Aptos"/>
               </a:rPr>
-              <a:t>SYNTHETIC DEVELOPMENT DATA | Not official Zidio or NorthBay Living results</a:t>
+              <a:t>FORESIGHT official-data readout (D1-D4) | Decision thresholds are assumptions for review</a:t>
             </a:r>
           </a:p>
         </p:txBody>
@@ -8171,7 +8147,7 @@
               </a:defRPr>
             </a:pPr>
             <a:r>
-              <a:t>All inputs are synthetic development data generated for testing; none are official internship or NorthBay Living extracts.</a:t>
+              <a:t>All forecasts and risk scores are computed from the official D1-D4 outputs; nothing is fabricated or sourced from legacy demo files.</a:t>
             </a:r>
           </a:p>
           <a:p>
@@ -8187,7 +8163,7 @@
               </a:defRPr>
             </a:pPr>
             <a:r>
-              <a:t>D4 thresholds are implementation assumptions and must be reviewed with the mentor/client.</a:t>
+              <a:t>D4 thresholds (coverage target, volatility cut-offs, decision matrix) are implementation assumptions and must be reviewed with the mentor/client.</a:t>
             </a:r>
           </a:p>
           <a:p>
@@ -8219,7 +8195,7 @@
               </a:defRPr>
             </a:pPr>
             <a:r>
-              <a:t>Forecast performance is measured on this synthetic history and should be recomputed on official data.</a:t>
+              <a:t>Forecast performance is measured with chronological rolling-origin folds on the official 25,000-transaction history and should be revisited as data grows.</a:t>
             </a:r>
           </a:p>
           <a:p>
@@ -8390,7 +8366,7 @@
                 </a:solidFill>
                 <a:latin typeface="Aptos"/>
               </a:rPr>
-              <a:t>A clean handoff from development evidence to official-data validation</a:t>
+              <a:t>Prioritised actions with honest forecast accuracy and clear assumptions</a:t>
             </a:r>
           </a:p>
         </p:txBody>
@@ -8425,7 +8401,7 @@
                 </a:solidFill>
                 <a:latin typeface="Aptos"/>
               </a:rPr>
-              <a:t>SYNTHETIC DEVELOPMENT DATA | Not official Zidio or NorthBay Living results</a:t>
+              <a:t>FORESIGHT official-data readout (D1-D4) | Decision thresholds are assumptions for review</a:t>
             </a:r>
           </a:p>
         </p:txBody>
@@ -8499,7 +8475,7 @@
               </a:defRPr>
             </a:pPr>
             <a:r>
-              <a:t>Use the prioritised queue to demonstrate the workflow.</a:t>
+              <a:t>Use the prioritised queue to review decisions.</a:t>
             </a:r>
           </a:p>
           <a:p>
@@ -8531,7 +8507,7 @@
               </a:defRPr>
             </a:pPr>
             <a:r>
-              <a:t>Keep synthetic findings clearly separated from company conclusions.</a:t>
+              <a:t>Keep observed metrics distinct from recommendations and thresholds.</a:t>
             </a:r>
           </a:p>
         </p:txBody>
@@ -8566,7 +8542,7 @@
                 </a:solidFill>
                 <a:latin typeface="Aptos"/>
               </a:rPr>
-              <a:t>When official extracts arrive</a:t>
+              <a:t>Before relying on outputs</a:t>
             </a:r>
           </a:p>
         </p:txBody>
@@ -8605,7 +8581,7 @@
               </a:defRPr>
             </a:pPr>
             <a:r>
-              <a:t>Replace the four raw CSVs without changing the contract.</a:t>
+              <a:t>Revisit D3 WAPE/bias and D4 valuation as the official data grows.</a:t>
             </a:r>
           </a:p>
           <a:p>
@@ -8621,7 +8597,7 @@
               </a:defRPr>
             </a:pPr>
             <a:r>
-              <a:t>Rerun D1 through D4 and compare data sufficiency, WAPE, bias, and risk exposure.</a:t>
+              <a:t>Compare updated data sufficiency and risk exposure across refreshes.</a:t>
             </a:r>
           </a:p>
           <a:p>
@@ -8715,7 +8691,7 @@
                 </a:solidFill>
                 <a:latin typeface="Aptos"/>
               </a:rPr>
-              <a:t>The development pipeline is ready for an honest, reproducible replacement with official data.</a:t>
+              <a:t>The pipeline is complete on the official data and ready for ongoing review and refresh.</a:t>
             </a:r>
           </a:p>
         </p:txBody>

</xml_diff>